<commit_message>
docs(presentation): correct scenario evidence and reviewer entry
Bind the two example attempts to the unchanged reference purchase,
stop implying admins can open other players reports, and split
the local launch steps for reviewers.

Co-authored-by: Cursor <cursoragent@cursor.com>
</commit_message>
<xml_diff>
--- a/docs/submission/TALKNFACE_PRODUCT_PITCH_RU.pptx
+++ b/docs/submission/TALKNFACE_PRODUCT_PITCH_RU.pptx
@@ -603,27 +603,22 @@
           <a:lstStyle/>
           <a:p>
             <a:r>
-              <a:t>5:35–6:20. Здесь переходите в живое демо по DEMO_GUIDE_RU.</a:t>
-            </a:r>
-          </a:p>
-          <a:p>
-            <a:r>
-              <a:t>Маршрут: admin → шесть полей supply/planned/normal/friendly/director/margin → проверить → опубликовать → подготовка → логистика → факт → довод → оплата → 95/split/50 → разбор → «Повторить ту же ситуацию».</a:t>
-            </a:r>
-          </a:p>
-          <a:p>
-            <a:r>
-              <a:t>Если демо недоступно: пройдите слайды 3–6 по скриншотам, затем S2 кадр «Цель достигнута».</a:t>
-            </a:r>
-          </a:p>
-          <a:p>
-            <a:r>
-              <a:t>Контактов команды в материалах нет — не выдумывайте имена. Источник — репозиторий владельца.</a:t>
-            </a:r>
-          </a:p>
-          <a:p>
-            <a:r>
-              <a:t>Анонимный GitHub сейчас 404: жюри нужен доступ или ZIP от владельца. QR на localhost нет и не будет.</a:t>
+              <a:t>5:20–5:40, затем живой показ 3–5 минут. Вместе с речью ориентир 8–12 минут. Официальный лимит мероприятия не выдумываем: его проверяет владелец.</a:t>
+            </a:r>
+          </a:p>
+          <a:p>
+            <a:r>
+              <a:t>Живой показ — настроенная плановая поставка, не эталон со слайда 4: дружелюбный тон, доходность, пакет 95 / 40% / 50, затем «Повторить ту же ситуацию». Маршрут в DEMO_GUIDE_RU.</a:t>
+            </a:r>
+          </a:p>
+          <a:p>
+            <a:r>
+              <a:t>Если сервер недоступен: слайды 3, 1, 4 и 6.</a:t>
+            </a:r>
+          </a:p>
+          <a:p>
+            <a:r>
+              <a:t>Контактов команды нет — не выдумывайте. QR нет: публичного адреса нет, localhost в код не кладём.</a:t>
             </a:r>
           </a:p>
         </p:txBody>
@@ -1038,27 +1033,32 @@
           <a:lstStyle/>
           <a:p>
             <a:r>
-              <a:t>1:45–2:35. Это синтетические попытки одной версии S1, не пилот у заказчика.</a:t>
-            </a:r>
-          </a:p>
-          <a:p>
-            <a:r>
-              <a:t>А — маршрут из сценария показа: полезность 64, процесс 100. Источники: DEMO_GUIDE, G5, G6, clean-machine.</a:t>
-            </a:r>
-          </a:p>
-          <a:p>
-            <a:r>
-              <a:t>Б — из таблицы G6: пакет в начале, затем исследование и выход. Соглашения нет, процесс 70. Зачёт «взаимный пакет» остаётся, потому что сделка для этой проверки не нужна.</a:t>
-            </a:r>
-          </a:p>
-          <a:p>
-            <a:r>
-              <a:t>Не говорите, что человек «стал компетентнее на 30 пунктов». Не переводите 64 в рубли.</a:t>
-            </a:r>
-          </a:p>
-          <a:p>
-            <a:r>
-              <a:t>Переход: «Тот же продукт работает и для разговора внутри команды.»</a:t>
+              <a:t>1:45–2:25. Обе попытки — неизменённый эталон S1 «Закупка к запуску»: запуск производства, обычная сложность, нейтральный тон, директор, оборотные средства. Источники: s1-supply-launch.ts, feedback.test.ts, e2e feedback.spec.ts. Это не настроенная плановая поставка живого показа.</a:t>
+            </a:r>
+          </a:p>
+          <a:p>
+            <a:r>
+              <a:t>А: полезность 64, процесс 100.</a:t>
+            </a:r>
+          </a:p>
+          <a:p>
+            <a:r>
+              <a:t>Б: тот же пакет первым, затем вопросы, затем явный выход без сделки. Соглашения нет, процесс 70. Не говорите, что сам порядок вопросов автоматически дал отказ: финал — потому что игрок вышел.</a:t>
+            </a:r>
+          </a:p>
+          <a:p>
+            <a:r>
+              <a:t>Не вычитайте 100 и 70 как рост компетенции. Не переводите 64 в рубли.</a:t>
+            </a:r>
+          </a:p>
+          <a:p>
+            <a:r>
+              <a:t>Живой показ отдельно: плановая поставка, дружелюбный тон, доходность.</a:t>
+            </a:r>
+          </a:p>
+          <a:p>
+            <a:r>
+              <a:t>Переход: «Тот же продукт — и для разговора о нагрузке.»</a:t>
             </a:r>
           </a:p>
         </p:txBody>
@@ -1218,32 +1218,27 @@
           <a:lstStyle/>
           <a:p>
             <a:r>
-              <a:t>3:15–4:00. Покажите разделение: сверху исход сделки, ниже процесс.</a:t>
-            </a:r>
-          </a:p>
-          <a:p>
-            <a:r>
-              <a:t>100: 7 применимых из 12, 5 зачётов прогресса, уступки «нет оценки» — не штраф.</a:t>
-            </a:r>
-          </a:p>
-          <a:p>
-            <a:r>
-              <a:t>44.12 в S2 — формула весов, не «человек на 44%».</a:t>
-            </a:r>
-          </a:p>
-          <a:p>
-            <a:r>
-              <a:t>Недостаточно наблюдений: нет подготовки или мало событий.</a:t>
-            </a:r>
-          </a:p>
-          <a:p>
-            <a:r>
-              <a:t>Ссылка «Ход 5» ведёт к фразе из той попытки, не к шаблону экрана.</a:t>
-            </a:r>
-          </a:p>
-          <a:p>
-            <a:r>
-              <a:t>Переход: «Кому это нужно после хакатона — как гипотеза, не как клиентский кейс.»</a:t>
+              <a:t>3:15–3:55. На экране — фрагмент настоящего разбора: проверка «взаимный пакет», объяснение и ссылка «Ход 5» на сохранённую фразу.</a:t>
+            </a:r>
+          </a:p>
+          <a:p>
+            <a:r>
+              <a:t>100 — 7 применимых проверок из 12, не компетенция человека.</a:t>
+            </a:r>
+          </a:p>
+          <a:p>
+            <a:r>
+              <a:t>44.12 в S2 — веса проверок, не «человек на 44%».</a:t>
+            </a:r>
+          </a:p>
+          <a:p>
+            <a:r>
+              <a:t>«Недостаточно наблюдений» — если нет явной подготовки или мало событий. Второй скриншот для этого не показываем: он был слишком мелким.</a:t>
+            </a:r>
+          </a:p>
+          <a:p>
+            <a:r>
+              <a:t>Переход: «Кому это нужно — как гипотеза, не как клиентский кейс.»</a:t>
             </a:r>
           </a:p>
         </p:txBody>
@@ -1313,27 +1308,27 @@
           <a:lstStyle/>
           <a:p>
             <a:r>
-              <a:t>4:00–4:35. Три роли, три разных обещания.</a:t>
-            </a:r>
-          </a:p>
-          <a:p>
-            <a:r>
-              <a:t>Игрок получает попытки. Организатор — настраиваемую сцену и материал для разговора.</a:t>
-            </a:r>
-          </a:p>
-          <a:p>
-            <a:r>
-              <a:t>Покупатель — сегмент, не выручка. Коммерческая модель и пилот — гипотеза.</a:t>
-            </a:r>
-          </a:p>
-          <a:p>
-            <a:r>
-              <a:t>Не говорите «заменим тренеров» и не называйте ОЭЗ партнёром продукта.</a:t>
-            </a:r>
-          </a:p>
-          <a:p>
-            <a:r>
-              <a:t>Переход: «Почему разбор можно проверять, а не верить модели на слово.»</a:t>
+              <a:t>4:00–4:30. Три роли.</a:t>
+            </a:r>
+          </a:p>
+          <a:p>
+            <a:r>
+              <a:t>Игрок получает свой отчёт. Администратор настраивает и публикует, но не открывает чужие попытки: такого обхода в продукте нет.</a:t>
+            </a:r>
+          </a:p>
+          <a:p>
+            <a:r>
+              <a:t>Наставник смотрит разбор вместе с игроком на его экране. Живого тренера не заменяем.</a:t>
+            </a:r>
+          </a:p>
+          <a:p>
+            <a:r>
+              <a:t>Покупатель — сегмент, не клиент. Алабуга — автор кейса.</a:t>
+            </a:r>
+          </a:p>
+          <a:p>
+            <a:r>
+              <a:t>Переход: «Почему одинаковые ходы дают одинаковый исход.»</a:t>
             </a:r>
           </a:p>
         </p:txBody>
@@ -1403,27 +1398,22 @@
           <a:lstStyle/>
           <a:p>
             <a:r>
-              <a:t>4:35–5:05. Диаграмма, не лекция про миграции.</a:t>
-            </a:r>
-          </a:p>
-          <a:p>
-            <a:r>
-              <a:t>Польза: воспроизводимость и проверяемость. Стек — одна строка.</a:t>
-            </a:r>
-          </a:p>
-          <a:p>
-            <a:r>
-              <a:t>Перезапуск: Stop/Start на том же порту, cookie жива — попытка продолжается. Это измерено на проверенном Windows-ПК, не обещание любой ОС.</a:t>
-            </a:r>
-          </a:p>
-          <a:p>
-            <a:r>
-              <a:t>Доступ: пароль администратора, cookie HttpOnly, чужой UUID не открывает попытку. Публичный HTTPS не делали.</a:t>
-            </a:r>
-          </a:p>
-          <a:p>
-            <a:r>
-              <a:t>Переход: «Что уже можно показать жюри и что честно ещё впереди.»</a:t>
+              <a:t>4:30–4:55. Три шага: экран, правила, сохранённый разбор.</a:t>
+            </a:r>
+          </a:p>
+          <a:p>
+            <a:r>
+              <a:t>Польза для человека: исход можно проверить по ходу.</a:t>
+            </a:r>
+          </a:p>
+          <a:p>
+            <a:r>
+              <a:t>Стек — одна строка. Локальный запуск, не сайт. Перезапуск с сохранением попытки измерен на одном Windows-ПК, не на любой системе.</a:t>
+            </a:r>
+          </a:p>
+          <a:p>
+            <a:r>
+              <a:t>Переход: «Что уже можно пройти и что ещё впереди.»</a:t>
             </a:r>
           </a:p>
         </p:txBody>
@@ -1493,27 +1483,17 @@
           <a:lstStyle/>
           <a:p>
             <a:r>
-              <a:t>5:05–5:35. Не начинайте питч с «у нас нет AI». Здесь — честная граница после показанной ценности.</a:t>
-            </a:r>
-          </a:p>
-          <a:p>
-            <a:r>
-              <a:t>Guided — рабочий продукт: выбор, последствия, объяснение, повтор.</a:t>
-            </a:r>
-          </a:p>
-          <a:p>
-            <a:r>
-              <a:t>Скачанный чекпоинт или обучение на другом компьютере не равны встроенной возможности.</a:t>
-            </a:r>
-          </a:p>
-          <a:p>
-            <a:r>
-              <a:t>Если спросят про Qwen: планируем свободнее вести диалог на тех же правилах сделки. Пока игрок выбирает действие из списка.</a:t>
-            </a:r>
-          </a:p>
-          <a:p>
-            <a:r>
-              <a:t>Переход: «Готовы показать прототип и откуда брать материалы.»</a:t>
+              <a:t>4:55–5:20. Граница после показанной ценности, не открытие питча.</a:t>
+            </a:r>
+          </a:p>
+          <a:p>
+            <a:r>
+              <a:t>Сейчас игрок выбирает действие из списка. Свободный текст и Qwen — следующий этап, не текущая возможность. Скачанная модель сама по себе продукт не включает.</a:t>
+            </a:r>
+          </a:p>
+          <a:p>
+            <a:r>
+              <a:t>Переход: «Давайте пройдём прототип.»</a:t>
             </a:r>
           </a:p>
         </p:txBody>
@@ -5756,7 +5736,7 @@
         <p:spPr>
           <a:xfrm>
             <a:off x="411480" y="420624"/>
-            <a:ext cx="11338560" cy="868680"/>
+            <a:ext cx="11338560" cy="777240"/>
           </a:xfrm>
           <a:prstGeom prst="rect">
             <a:avLst/>
@@ -5784,7 +5764,7 @@
                 <a:ea typeface="Segoe UI"/>
                 <a:cs typeface="Segoe UI"/>
               </a:rPr>
-              <a:t>Прототип можно пройти: настройка, переговоры, разбор</a:t>
+              <a:t>Пройдите прототип: настройка, переговоры, разбор</a:t>
             </a:r>
           </a:p>
         </p:txBody>
@@ -5797,8 +5777,8 @@
         </p:nvSpPr>
         <p:spPr>
           <a:xfrm>
-            <a:off x="411480" y="1417320"/>
-            <a:ext cx="6675120" cy="822960"/>
+            <a:off x="411480" y="1371600"/>
+            <a:ext cx="11338560" cy="640080"/>
           </a:xfrm>
           <a:prstGeom prst="rect">
             <a:avLst/>
@@ -5826,7 +5806,7 @@
                 <a:ea typeface="Calibri"/>
                 <a:cs typeface="Calibri"/>
               </a:rPr>
-              <a:t>Отрепетируйте сложный разговор до реальной встречи — на этой машине, в guided-режиме, без ключей.</a:t>
+              <a:t>Отрепетируйте сложный разговор до реальной встречи. Выбор действий, без ключей и без модели.</a:t>
             </a:r>
           </a:p>
         </p:txBody>
@@ -5839,8 +5819,8 @@
         </p:nvSpPr>
         <p:spPr>
           <a:xfrm>
-            <a:off x="411480" y="2286000"/>
-            <a:ext cx="6675120" cy="3840480"/>
+            <a:off x="411480" y="2194560"/>
+            <a:ext cx="6858000" cy="3931920"/>
           </a:xfrm>
           <a:prstGeom prst="roundRect">
             <a:avLst>
@@ -5886,8 +5866,8 @@
         </p:nvSpPr>
         <p:spPr>
           <a:xfrm>
-            <a:off x="640080" y="2468880"/>
-            <a:ext cx="6263640" cy="320040"/>
+            <a:off x="640080" y="2377440"/>
+            <a:ext cx="6446520" cy="365760"/>
           </a:xfrm>
           <a:prstGeom prst="rect">
             <a:avLst/>
@@ -5915,7 +5895,7 @@
                 <a:ea typeface="Segoe UI"/>
                 <a:cs typeface="Segoe UI"/>
               </a:rPr>
-              <a:t>Что открыть</a:t>
+              <a:t>Материалы для жюри</a:t>
             </a:r>
           </a:p>
         </p:txBody>
@@ -5929,7 +5909,7 @@
         <p:spPr>
           <a:xfrm>
             <a:off x="640080" y="2880360"/>
-            <a:ext cx="6263640" cy="3017520"/>
+            <a:ext cx="6446520" cy="640080"/>
           </a:xfrm>
           <a:prstGeom prst="rect">
             <a:avLst/>
@@ -5949,7 +5929,7 @@
               </a:spcAft>
             </a:pPr>
             <a:r>
-              <a:rPr sz="1500" b="0">
+              <a:rPr sz="1600" b="0">
                 <a:solidFill>
                   <a:srgbClr val="203240"/>
                 </a:solidFill>
@@ -5957,27 +5937,106 @@
                 <a:ea typeface="Calibri"/>
                 <a:cs typeface="Calibri"/>
               </a:rPr>
-              <a:t>Презентация: docs/submission/TALKNFACE_PRODUCT_PITCH_RU.pptx
-Вход рецензента: docs/submission/README.md
-Показ 3–5 мин: docs/DEMO_GUIDE_RU.md
-Код приложения: feature/app-qwen-independent-01
-Эта поставка слайдов: docs/organizer-presentation-01
-Репозиторий сейчас закрыт для анонимного чтения:
-нужны права или ZIP владельца.</a:t>
-            </a:r>
-          </a:p>
-        </p:txBody>
-      </p:sp>
-      <p:sp>
-        <p:nvSpPr>
-          <p:cNvPr id="9" name="Rounded Rectangle 8"/>
+              <a:t>Одна страница: исходники, запуск, презентация и описание продукта.</a:t>
+            </a:r>
+          </a:p>
+        </p:txBody>
+      </p:sp>
+      <p:sp>
+        <p:nvSpPr>
+          <p:cNvPr id="9" name="TextBox 8"/>
+          <p:cNvSpPr txBox="1"/>
+          <p:nvPr/>
+        </p:nvSpPr>
+        <p:spPr>
+          <a:xfrm>
+            <a:off x="640080" y="3566160"/>
+            <a:ext cx="6446520" cy="411480"/>
+          </a:xfrm>
+          <a:prstGeom prst="rect">
+            <a:avLst/>
+          </a:prstGeom>
+          <a:noFill/>
+        </p:spPr>
+        <p:txBody>
+          <a:bodyPr wrap="square"/>
+          <a:lstStyle/>
+          <a:p>
+            <a:pPr algn="l">
+              <a:spcBef>
+                <a:spcPts val="0"/>
+              </a:spcBef>
+              <a:spcAft>
+                <a:spcPts val="0"/>
+              </a:spcAft>
+            </a:pPr>
+            <a:r>
+              <a:rPr sz="1800" b="1">
+                <a:solidFill>
+                  <a:srgbClr val="17695E"/>
+                </a:solidFill>
+                <a:latin typeface="Segoe UI"/>
+                <a:ea typeface="Segoe UI"/>
+                <a:cs typeface="Segoe UI"/>
+                <a:hlinkClick r:id="rId2"/>
+              </a:rPr>
+              <a:t>Открыть страницу материалов</a:t>
+            </a:r>
+          </a:p>
+        </p:txBody>
+      </p:sp>
+      <p:sp>
+        <p:nvSpPr>
+          <p:cNvPr id="10" name="TextBox 9"/>
+          <p:cNvSpPr txBox="1"/>
+          <p:nvPr/>
+        </p:nvSpPr>
+        <p:spPr>
+          <a:xfrm>
+            <a:off x="640080" y="4114800"/>
+            <a:ext cx="6446520" cy="1645920"/>
+          </a:xfrm>
+          <a:prstGeom prst="rect">
+            <a:avLst/>
+          </a:prstGeom>
+          <a:noFill/>
+        </p:spPr>
+        <p:txBody>
+          <a:bodyPr wrap="square"/>
+          <a:lstStyle/>
+          <a:p>
+            <a:pPr algn="l">
+              <a:spcBef>
+                <a:spcPts val="0"/>
+              </a:spcBef>
+              <a:spcAft>
+                <a:spcPts val="0"/>
+              </a:spcAft>
+            </a:pPr>
+            <a:r>
+              <a:rPr sz="1500" b="0">
+                <a:solidFill>
+                  <a:srgbClr val="586B72"/>
+                </a:solidFill>
+                <a:latin typeface="Calibri"/>
+                <a:ea typeface="Calibri"/>
+                <a:cs typeface="Calibri"/>
+              </a:rPr>
+              <a:t>Ссылка ведёт в репозиторий. Анонимно он сейчас не открывается: нужен доступ владельца или ZIP. Это не публичный сайт продукта.</a:t>
+            </a:r>
+          </a:p>
+        </p:txBody>
+      </p:sp>
+      <p:sp>
+        <p:nvSpPr>
+          <p:cNvPr id="11" name="Rounded Rectangle 10"/>
           <p:cNvSpPr/>
           <p:nvPr/>
         </p:nvSpPr>
         <p:spPr>
           <a:xfrm>
-            <a:off x="7269480" y="2286000"/>
-            <a:ext cx="4480560" cy="3840480"/>
+            <a:off x="7452360" y="2194560"/>
+            <a:ext cx="4297680" cy="3931920"/>
           </a:xfrm>
           <a:prstGeom prst="roundRect">
             <a:avLst>
@@ -6015,14 +6074,14 @@
       </p:sp>
       <p:sp>
         <p:nvSpPr>
-          <p:cNvPr id="10" name="TextBox 9"/>
-          <p:cNvSpPr txBox="1"/>
-          <p:nvPr/>
-        </p:nvSpPr>
-        <p:spPr>
-          <a:xfrm>
-            <a:off x="7498079" y="2468880"/>
-            <a:ext cx="4069080" cy="365760"/>
+          <p:cNvPr id="12" name="TextBox 11"/>
+          <p:cNvSpPr txBox="1"/>
+          <p:nvPr/>
+        </p:nvSpPr>
+        <p:spPr>
+          <a:xfrm>
+            <a:off x="7680960" y="2423160"/>
+            <a:ext cx="3886200" cy="640080"/>
           </a:xfrm>
           <a:prstGeom prst="rect">
             <a:avLst/>
@@ -6050,21 +6109,21 @@
                 <a:ea typeface="Segoe UI"/>
                 <a:cs typeface="Segoe UI"/>
               </a:rPr>
-              <a:t>Запуск на Windows</a:t>
-            </a:r>
-          </a:p>
-        </p:txBody>
-      </p:sp>
-      <p:sp>
-        <p:nvSpPr>
-          <p:cNvPr id="11" name="TextBox 10"/>
-          <p:cNvSpPr txBox="1"/>
-          <p:nvPr/>
-        </p:nvSpPr>
-        <p:spPr>
-          <a:xfrm>
-            <a:off x="7498079" y="2926080"/>
-            <a:ext cx="4069080" cy="2926080"/>
+              <a:t>После запуска на этом компьютере</a:t>
+            </a:r>
+          </a:p>
+        </p:txBody>
+      </p:sp>
+      <p:sp>
+        <p:nvSpPr>
+          <p:cNvPr id="13" name="TextBox 12"/>
+          <p:cNvSpPr txBox="1"/>
+          <p:nvPr/>
+        </p:nvSpPr>
+        <p:spPr>
+          <a:xfrm>
+            <a:off x="7680960" y="3200400"/>
+            <a:ext cx="3886200" cy="2377440"/>
           </a:xfrm>
           <a:prstGeom prst="rect">
             <a:avLst/>
@@ -6084,7 +6143,7 @@
               </a:spcAft>
             </a:pPr>
             <a:r>
-              <a:rPr sz="1600" b="0">
+              <a:rPr sz="1800" b="0">
                 <a:solidFill>
                   <a:srgbClr val="FFFFFF"/>
                 </a:solidFill>
@@ -6092,19 +6151,17 @@
                 <a:ea typeface="Calibri"/>
                 <a:cs typeface="Calibri"/>
               </a:rPr>
-              <a:t>Prepare
-Start -Port 3100
-Stop
-http://127.0.0.1:3100/admin
-Это локальный контур, не сайт.
-Пароль задаёте вы. Модель не нужна.</a:t>
-            </a:r>
-          </a:p>
-        </p:txBody>
-      </p:sp>
-      <p:sp>
-        <p:nvSpPr>
-          <p:cNvPr id="12" name="TextBox 11"/>
+              <a:t>127.0.0.1:3100/admin
+Только здесь, не удалённое демо.
+Свой пароль.
+Модель не нужна.</a:t>
+            </a:r>
+          </a:p>
+        </p:txBody>
+      </p:sp>
+      <p:sp>
+        <p:nvSpPr>
+          <p:cNvPr id="14" name="TextBox 13"/>
           <p:cNvSpPr txBox="1"/>
           <p:nvPr/>
         </p:nvSpPr>
@@ -6146,7 +6203,7 @@
       </p:sp>
       <p:sp>
         <p:nvSpPr>
-          <p:cNvPr id="13" name="TextBox 12"/>
+          <p:cNvPr id="15" name="TextBox 14"/>
           <p:cNvSpPr txBox="1"/>
           <p:nvPr/>
         </p:nvSpPr>
@@ -6868,7 +6925,7 @@
                 <a:ea typeface="Calibri"/>
                 <a:cs typeface="Calibri"/>
               </a:rPr>
-              <a:t>Настройки → публикация → подготовка → ветвящиеся ходы → исход → разбор → replay.</a:t>
+              <a:t>Настройки, публикация, подготовка, ходы, исход, разбор, повторная попытка.</a:t>
             </a:r>
           </a:p>
         </p:txBody>
@@ -7580,7 +7637,7 @@
                 <a:ea typeface="Calibri"/>
                 <a:cs typeface="Calibri"/>
               </a:rPr>
-              <a:t>Локальный Windows-контур по инструкции. Публичной ссылки нет.</a:t>
+              <a:t>Локальный запуск на Windows по инструкции. Публичной ссылки нет.</a:t>
             </a:r>
           </a:p>
         </p:txBody>
@@ -7758,7 +7815,7 @@
                 <a:ea typeface="Calibri"/>
                 <a:cs typeface="Calibri"/>
               </a:rPr>
-              <a:t>Guided без AI. Свободный диалог и публичный хостинг — следующие шаги.</a:t>
+              <a:t>Выбор действий, без AI. Свободный диалог — следующий шаг.</a:t>
             </a:r>
           </a:p>
         </p:txBody>
@@ -8519,7 +8576,7 @@
                 <a:ea typeface="Calibri"/>
                 <a:cs typeface="Calibri"/>
               </a:rPr>
-              <a:t>Локальный SQLite. Нет регистрации игрока. Чужой идентификатор попытку не открывает. Это loopback, не GDPR-аудит.</a:t>
+              <a:t>Локальная база. Регистрации игрока нет. Чужой адрес попытку не открывает. Это локальный запуск, не публичный сайт.</a:t>
             </a:r>
           </a:p>
         </p:txBody>
@@ -8781,7 +8838,7 @@
                 <a:ea typeface="Calibri"/>
                 <a:cs typeface="Calibri"/>
               </a:rPr>
-              <a:t>Linux/macOS, другой браузер, публичный HTTPS, чужой ПК жюри, качество модели.</a:t>
+              <a:t>Linux и macOS, другой браузер, публичный сайт, чужой компьютер жюри, качество модели.</a:t>
             </a:r>
           </a:p>
         </p:txBody>
@@ -10880,7 +10937,7 @@
         <p:spPr>
           <a:xfrm>
             <a:off x="411480" y="420624"/>
-            <a:ext cx="11338560" cy="868680"/>
+            <a:ext cx="11338560" cy="640080"/>
           </a:xfrm>
           <a:prstGeom prst="rect">
             <a:avLst/>
@@ -10900,7 +10957,7 @@
               </a:spcAft>
             </a:pPr>
             <a:r>
-              <a:rPr sz="2800" b="1">
+              <a:rPr sz="2600" b="1">
                 <a:solidFill>
                   <a:srgbClr val="183331"/>
                 </a:solidFill>
@@ -10915,14 +10972,56 @@
       </p:sp>
       <p:sp>
         <p:nvSpPr>
-          <p:cNvPr id="5" name="Rounded Rectangle 4"/>
+          <p:cNvPr id="5" name="TextBox 4"/>
+          <p:cNvSpPr txBox="1"/>
+          <p:nvPr/>
+        </p:nvSpPr>
+        <p:spPr>
+          <a:xfrm>
+            <a:off x="411480" y="1115568"/>
+            <a:ext cx="11338560" cy="502920"/>
+          </a:xfrm>
+          <a:prstGeom prst="rect">
+            <a:avLst/>
+          </a:prstGeom>
+          <a:noFill/>
+        </p:spPr>
+        <p:txBody>
+          <a:bodyPr wrap="square"/>
+          <a:lstStyle/>
+          <a:p>
+            <a:pPr algn="l">
+              <a:spcBef>
+                <a:spcPts val="0"/>
+              </a:spcBef>
+              <a:spcAft>
+                <a:spcPts val="0"/>
+              </a:spcAft>
+            </a:pPr>
+            <a:r>
+              <a:rPr sz="1400" b="0">
+                <a:solidFill>
+                  <a:srgbClr val="586B72"/>
+                </a:solidFill>
+                <a:latin typeface="Calibri"/>
+                <a:ea typeface="Calibri"/>
+                <a:cs typeface="Calibri"/>
+              </a:rPr>
+              <a:t>Обе попытки — неизменённый эталон «Закупка к запуску»: обычная сложность, нейтральный тон, директор продаж, оборотные средства. Живой показ использует другую, настроенную версию.</a:t>
+            </a:r>
+          </a:p>
+        </p:txBody>
+      </p:sp>
+      <p:sp>
+        <p:nvSpPr>
+          <p:cNvPr id="6" name="Rounded Rectangle 5"/>
           <p:cNvSpPr/>
           <p:nvPr/>
         </p:nvSpPr>
         <p:spPr>
           <a:xfrm>
-            <a:off x="411480" y="1417320"/>
-            <a:ext cx="5577840" cy="4709160"/>
+            <a:off x="411480" y="1737360"/>
+            <a:ext cx="5577840" cy="4480560"/>
           </a:xfrm>
           <a:prstGeom prst="roundRect">
             <a:avLst>
@@ -10962,14 +11061,14 @@
       </p:sp>
       <p:sp>
         <p:nvSpPr>
-          <p:cNvPr id="6" name="Rectangle 5"/>
+          <p:cNvPr id="7" name="Rectangle 6"/>
           <p:cNvSpPr/>
           <p:nvPr/>
         </p:nvSpPr>
         <p:spPr>
           <a:xfrm>
-            <a:off x="411480" y="1417320"/>
-            <a:ext cx="5577840" cy="109728"/>
+            <a:off x="411480" y="1737360"/>
+            <a:ext cx="5577840" cy="91440"/>
           </a:xfrm>
           <a:prstGeom prst="rect">
             <a:avLst/>
@@ -11005,13 +11104,13 @@
       </p:sp>
       <p:sp>
         <p:nvSpPr>
-          <p:cNvPr id="7" name="TextBox 6"/>
-          <p:cNvSpPr txBox="1"/>
-          <p:nvPr/>
-        </p:nvSpPr>
-        <p:spPr>
-          <a:xfrm>
-            <a:off x="640080" y="1691640"/>
+          <p:cNvPr id="8" name="TextBox 7"/>
+          <p:cNvSpPr txBox="1"/>
+          <p:nvPr/>
+        </p:nvSpPr>
+        <p:spPr>
+          <a:xfrm>
+            <a:off x="640080" y="1965960"/>
             <a:ext cx="5120640" cy="365760"/>
           </a:xfrm>
           <a:prstGeom prst="rect">
@@ -11040,21 +11139,21 @@
                 <a:ea typeface="Segoe UI"/>
                 <a:cs typeface="Segoe UI"/>
               </a:rPr>
-              <a:t>Попытка А. Сначала слушает</a:t>
-            </a:r>
-          </a:p>
-        </p:txBody>
-      </p:sp>
-      <p:sp>
-        <p:nvSpPr>
-          <p:cNvPr id="8" name="TextBox 7"/>
-          <p:cNvSpPr txBox="1"/>
-          <p:nvPr/>
-        </p:nvSpPr>
-        <p:spPr>
-          <a:xfrm>
-            <a:off x="640080" y="2194560"/>
-            <a:ext cx="5120640" cy="1554480"/>
+              <a:t>А. Сначала слушает</a:t>
+            </a:r>
+          </a:p>
+        </p:txBody>
+      </p:sp>
+      <p:sp>
+        <p:nvSpPr>
+          <p:cNvPr id="9" name="TextBox 8"/>
+          <p:cNvSpPr txBox="1"/>
+          <p:nvPr/>
+        </p:nvSpPr>
+        <p:spPr>
+          <a:xfrm>
+            <a:off x="640080" y="2423160"/>
+            <a:ext cx="5120640" cy="1417320"/>
           </a:xfrm>
           <a:prstGeom prst="rect">
             <a:avLst/>
@@ -11082,21 +11181,21 @@
                 <a:ea typeface="Calibri"/>
                 <a:cs typeface="Calibri"/>
               </a:rPr>
-              <a:t>Вопрос о логистике → признаёт экономию на разделении партии → логистический довод → вопрос об оплате → пакет 95 / 40% на день 7, остаток на 14 / предоплата 50%.</a:t>
-            </a:r>
-          </a:p>
-        </p:txBody>
-      </p:sp>
-      <p:sp>
-        <p:nvSpPr>
-          <p:cNvPr id="9" name="Rounded Rectangle 8"/>
+              <a:t>Вопрос о логистике, признание экономии, довод, вопрос об оплате. Затем пакет: 95 / 40% на день 7, остаток на 14 / предоплата 50%.</a:t>
+            </a:r>
+          </a:p>
+        </p:txBody>
+      </p:sp>
+      <p:sp>
+        <p:nvSpPr>
+          <p:cNvPr id="10" name="Rounded Rectangle 9"/>
           <p:cNvSpPr/>
           <p:nvPr/>
         </p:nvSpPr>
         <p:spPr>
           <a:xfrm>
-            <a:off x="640080" y="3886200"/>
-            <a:ext cx="5074920" cy="1920240"/>
+            <a:off x="640080" y="4023360"/>
+            <a:ext cx="5074920" cy="1874519"/>
           </a:xfrm>
           <a:prstGeom prst="roundRect">
             <a:avLst>
@@ -11136,13 +11235,13 @@
       </p:sp>
       <p:sp>
         <p:nvSpPr>
-          <p:cNvPr id="10" name="TextBox 9"/>
-          <p:cNvSpPr txBox="1"/>
-          <p:nvPr/>
-        </p:nvSpPr>
-        <p:spPr>
-          <a:xfrm>
-            <a:off x="822960" y="4069080"/>
+          <p:cNvPr id="11" name="TextBox 10"/>
+          <p:cNvSpPr txBox="1"/>
+          <p:nvPr/>
+        </p:nvSpPr>
+        <p:spPr>
+          <a:xfrm>
+            <a:off x="822960" y="4160520"/>
             <a:ext cx="4754880" cy="1600200"/>
           </a:xfrm>
           <a:prstGeom prst="rect">
@@ -11171,23 +11270,22 @@
                 <a:ea typeface="Calibri"/>
                 <a:cs typeface="Calibri"/>
               </a:rPr>
-              <a:t>Соглашение.
-Учебная полезность 64 — выше цели 62 и альтернативы 55.
-Процесс: 100 из 100 по 7 применимым проверкам.</a:t>
-            </a:r>
-          </a:p>
-        </p:txBody>
-      </p:sp>
-      <p:sp>
-        <p:nvSpPr>
-          <p:cNvPr id="11" name="Rounded Rectangle 10"/>
+              <a:t>Соглашение. Полезность 64 — выше цели 62 и альтернативы 55.
+Процесс 100 по 7 применимым проверкам.</a:t>
+            </a:r>
+          </a:p>
+        </p:txBody>
+      </p:sp>
+      <p:sp>
+        <p:nvSpPr>
+          <p:cNvPr id="12" name="Rounded Rectangle 11"/>
           <p:cNvSpPr/>
           <p:nvPr/>
         </p:nvSpPr>
         <p:spPr>
           <a:xfrm>
-            <a:off x="6172200" y="1417320"/>
-            <a:ext cx="5577840" cy="4709160"/>
+            <a:off x="6172200" y="1737360"/>
+            <a:ext cx="5577840" cy="4480560"/>
           </a:xfrm>
           <a:prstGeom prst="roundRect">
             <a:avLst>
@@ -11227,14 +11325,14 @@
       </p:sp>
       <p:sp>
         <p:nvSpPr>
-          <p:cNvPr id="12" name="Rectangle 11"/>
+          <p:cNvPr id="13" name="Rectangle 12"/>
           <p:cNvSpPr/>
           <p:nvPr/>
         </p:nvSpPr>
         <p:spPr>
           <a:xfrm>
-            <a:off x="6172200" y="1417320"/>
-            <a:ext cx="5577840" cy="109728"/>
+            <a:off x="6172200" y="1737360"/>
+            <a:ext cx="5577840" cy="91440"/>
           </a:xfrm>
           <a:prstGeom prst="rect">
             <a:avLst/>
@@ -11270,13 +11368,13 @@
       </p:sp>
       <p:sp>
         <p:nvSpPr>
-          <p:cNvPr id="13" name="TextBox 12"/>
-          <p:cNvSpPr txBox="1"/>
-          <p:nvPr/>
-        </p:nvSpPr>
-        <p:spPr>
-          <a:xfrm>
-            <a:off x="6400800" y="1691640"/>
+          <p:cNvPr id="14" name="TextBox 13"/>
+          <p:cNvSpPr txBox="1"/>
+          <p:nvPr/>
+        </p:nvSpPr>
+        <p:spPr>
+          <a:xfrm>
+            <a:off x="6400800" y="1965960"/>
             <a:ext cx="5120640" cy="365760"/>
           </a:xfrm>
           <a:prstGeom prst="rect">
@@ -11305,21 +11403,21 @@
                 <a:ea typeface="Segoe UI"/>
                 <a:cs typeface="Segoe UI"/>
               </a:rPr>
-              <a:t>Попытка Б. Сначала предлагает</a:t>
-            </a:r>
-          </a:p>
-        </p:txBody>
-      </p:sp>
-      <p:sp>
-        <p:nvSpPr>
-          <p:cNvPr id="14" name="TextBox 13"/>
-          <p:cNvSpPr txBox="1"/>
-          <p:nvPr/>
-        </p:nvSpPr>
-        <p:spPr>
-          <a:xfrm>
-            <a:off x="6400800" y="2194560"/>
-            <a:ext cx="5120640" cy="1554480"/>
+              <a:t>Б. Предлагает и выходит</a:t>
+            </a:r>
+          </a:p>
+        </p:txBody>
+      </p:sp>
+      <p:sp>
+        <p:nvSpPr>
+          <p:cNvPr id="15" name="TextBox 14"/>
+          <p:cNvSpPr txBox="1"/>
+          <p:nvPr/>
+        </p:nvSpPr>
+        <p:spPr>
+          <a:xfrm>
+            <a:off x="6400800" y="2423160"/>
+            <a:ext cx="5120640" cy="1417320"/>
           </a:xfrm>
           <a:prstGeom prst="rect">
             <a:avLst/>
@@ -11347,21 +11445,21 @@
                 <a:ea typeface="Calibri"/>
                 <a:cs typeface="Calibri"/>
               </a:rPr>
-              <a:t>Тот же взаимный пакет уходит первым ходом, затем вопросы и выход без сделки. Конфигурация та же: закупка, плановая поставка, обычная сложность, дружелюбный тон, директор, доходность.</a:t>
-            </a:r>
-          </a:p>
-        </p:txBody>
-      </p:sp>
-      <p:sp>
-        <p:nvSpPr>
-          <p:cNvPr id="15" name="Rounded Rectangle 14"/>
+              <a:t>Тот же пакет — первым ходом, затем вопросы. Игрок сам выбирает выход без сделки.</a:t>
+            </a:r>
+          </a:p>
+        </p:txBody>
+      </p:sp>
+      <p:sp>
+        <p:nvSpPr>
+          <p:cNvPr id="16" name="Rounded Rectangle 15"/>
           <p:cNvSpPr/>
           <p:nvPr/>
         </p:nvSpPr>
         <p:spPr>
           <a:xfrm>
-            <a:off x="6400800" y="3886200"/>
-            <a:ext cx="5074920" cy="1920240"/>
+            <a:off x="6400800" y="4023360"/>
+            <a:ext cx="5074920" cy="1874519"/>
           </a:xfrm>
           <a:prstGeom prst="roundRect">
             <a:avLst>
@@ -11401,13 +11499,13 @@
       </p:sp>
       <p:sp>
         <p:nvSpPr>
-          <p:cNvPr id="16" name="TextBox 15"/>
-          <p:cNvSpPr txBox="1"/>
-          <p:nvPr/>
-        </p:nvSpPr>
-        <p:spPr>
-          <a:xfrm>
-            <a:off x="6583680" y="4069080"/>
+          <p:cNvPr id="17" name="TextBox 16"/>
+          <p:cNvSpPr txBox="1"/>
+          <p:nvPr/>
+        </p:nvSpPr>
+        <p:spPr>
+          <a:xfrm>
+            <a:off x="6583680" y="4160520"/>
             <a:ext cx="4754880" cy="1600200"/>
           </a:xfrm>
           <a:prstGeom prst="rect">
@@ -11436,16 +11534,15 @@
                 <a:ea typeface="Calibri"/>
                 <a:cs typeface="Calibri"/>
               </a:rPr>
-              <a:t>Соглашения нет. Полезности сделки нет.
-Процесс: 70 — зачёт за взаимный пакет сохраняется.
-Отказ — не провал процесса. Баллы не вычитаем как «рост навыка».</a:t>
-            </a:r>
-          </a:p>
-        </p:txBody>
-      </p:sp>
-      <p:sp>
-        <p:nvSpPr>
-          <p:cNvPr id="17" name="TextBox 16"/>
+              <a:t>Соглашения нет. Процесс 70: зачёт за взаимный пакет остаётся.
+Это выбор выхода, не рост навыка.</a:t>
+            </a:r>
+          </a:p>
+        </p:txBody>
+      </p:sp>
+      <p:sp>
+        <p:nvSpPr>
+          <p:cNvPr id="18" name="TextBox 17"/>
           <p:cNvSpPr txBox="1"/>
           <p:nvPr/>
         </p:nvSpPr>
@@ -11487,7 +11584,7 @@
       </p:sp>
       <p:sp>
         <p:nvSpPr>
-          <p:cNvPr id="18" name="TextBox 17"/>
+          <p:cNvPr id="19" name="TextBox 18"/>
           <p:cNvSpPr txBox="1"/>
           <p:nvPr/>
         </p:nvSpPr>
@@ -12330,7 +12427,7 @@
                 <a:ea typeface="Calibri"/>
                 <a:cs typeface="Calibri"/>
               </a:rPr>
-              <a:t>Когда оппонент раскрывает интерес и насколько жёстко принимает пакет. Всегда 8 ходов.</a:t>
+              <a:t>Когда оппонент раскрывает интерес и насколько жёстко принимает пакет. До 8 ходов.</a:t>
             </a:r>
           </a:p>
         </p:txBody>
@@ -12932,7 +13029,7 @@
         <p:spPr>
           <a:xfrm>
             <a:off x="411480" y="420624"/>
-            <a:ext cx="11338560" cy="822960"/>
+            <a:ext cx="11338560" cy="640080"/>
           </a:xfrm>
           <a:prstGeom prst="rect">
             <a:avLst/>
@@ -12952,7 +13049,7 @@
               </a:spcAft>
             </a:pPr>
             <a:r>
-              <a:rPr sz="2700" b="1">
+              <a:rPr sz="2600" b="1">
                 <a:solidFill>
                   <a:srgbClr val="183331"/>
                 </a:solidFill>
@@ -12965,40 +13062,16 @@
           </a:p>
         </p:txBody>
       </p:sp>
-      <p:pic>
-        <p:nvPicPr>
-          <p:cNvPr id="5" name="Picture 4" descr="process100.png"/>
-          <p:cNvPicPr>
-            <a:picLocks noChangeAspect="1"/>
-          </p:cNvPicPr>
-          <p:nvPr/>
-        </p:nvPicPr>
-        <p:blipFill>
-          <a:blip r:embed="rId2"/>
-          <a:stretch>
-            <a:fillRect/>
-          </a:stretch>
-        </p:blipFill>
-        <p:spPr>
-          <a:xfrm>
-            <a:off x="746439" y="1417320"/>
-            <a:ext cx="2576200" cy="4892040"/>
-          </a:xfrm>
-          <a:prstGeom prst="rect">
-            <a:avLst/>
-          </a:prstGeom>
-        </p:spPr>
-      </p:pic>
-      <p:sp>
-        <p:nvSpPr>
-          <p:cNvPr id="6" name="Rounded Rectangle 5"/>
+      <p:sp>
+        <p:nvSpPr>
+          <p:cNvPr id="5" name="Rounded Rectangle 4"/>
           <p:cNvSpPr/>
           <p:nvPr/>
         </p:nvSpPr>
         <p:spPr>
           <a:xfrm>
-            <a:off x="3840480" y="1417320"/>
-            <a:ext cx="3977639" cy="2240280"/>
+            <a:off x="411480" y="1280160"/>
+            <a:ext cx="4709160" cy="4983480"/>
           </a:xfrm>
           <a:prstGeom prst="roundRect">
             <a:avLst>
@@ -13036,100 +13109,40 @@
           </a:p>
         </p:txBody>
       </p:sp>
-      <p:sp>
-        <p:nvSpPr>
-          <p:cNvPr id="7" name="TextBox 6"/>
-          <p:cNvSpPr txBox="1"/>
-          <p:nvPr/>
-        </p:nvSpPr>
-        <p:spPr>
-          <a:xfrm>
-            <a:off x="4023360" y="1554480"/>
-            <a:ext cx="3657600" cy="365760"/>
-          </a:xfrm>
-          <a:prstGeom prst="rect">
-            <a:avLst/>
-          </a:prstGeom>
-          <a:noFill/>
-        </p:spPr>
-        <p:txBody>
-          <a:bodyPr wrap="square"/>
-          <a:lstStyle/>
-          <a:p>
-            <a:pPr algn="l">
-              <a:spcBef>
-                <a:spcPts val="0"/>
-              </a:spcBef>
-              <a:spcAft>
-                <a:spcPts val="0"/>
-              </a:spcAft>
-            </a:pPr>
-            <a:r>
-              <a:rPr sz="1600" b="1">
-                <a:solidFill>
-                  <a:srgbClr val="183331"/>
-                </a:solidFill>
-                <a:latin typeface="Segoe UI"/>
-                <a:ea typeface="Segoe UI"/>
-                <a:cs typeface="Segoe UI"/>
-              </a:rPr>
-              <a:t>Сделка ≠ процесс</a:t>
-            </a:r>
-          </a:p>
-        </p:txBody>
-      </p:sp>
-      <p:sp>
-        <p:nvSpPr>
-          <p:cNvPr id="8" name="TextBox 7"/>
-          <p:cNvSpPr txBox="1"/>
-          <p:nvPr/>
-        </p:nvSpPr>
-        <p:spPr>
-          <a:xfrm>
-            <a:off x="4023360" y="1965960"/>
-            <a:ext cx="3657600" cy="1463040"/>
-          </a:xfrm>
-          <a:prstGeom prst="rect">
-            <a:avLst/>
-          </a:prstGeom>
-          <a:noFill/>
-        </p:spPr>
-        <p:txBody>
-          <a:bodyPr wrap="square"/>
-          <a:lstStyle/>
-          <a:p>
-            <a:pPr algn="l">
-              <a:spcBef>
-                <a:spcPts val="0"/>
-              </a:spcBef>
-              <a:spcAft>
-                <a:spcPts val="0"/>
-              </a:spcAft>
-            </a:pPr>
-            <a:r>
-              <a:rPr sz="1400" b="0">
-                <a:solidFill>
-                  <a:srgbClr val="203240"/>
-                </a:solidFill>
-                <a:latin typeface="Calibri"/>
-                <a:ea typeface="Calibri"/>
-                <a:cs typeface="Calibri"/>
-              </a:rPr>
-              <a:t>Полезность сделки — про пакет. Балл процесса — про записанные действия учебной модели. 100 из 100 — не «100% компетентности переговорщика».</a:t>
-            </a:r>
-          </a:p>
-        </p:txBody>
-      </p:sp>
-      <p:sp>
-        <p:nvSpPr>
-          <p:cNvPr id="9" name="Rounded Rectangle 8"/>
+      <p:pic>
+        <p:nvPicPr>
+          <p:cNvPr id="6" name="Picture 5" descr="evidence.png"/>
+          <p:cNvPicPr>
+            <a:picLocks noChangeAspect="1"/>
+          </p:cNvPicPr>
+          <p:nvPr/>
+        </p:nvPicPr>
+        <p:blipFill>
+          <a:blip r:embed="rId2"/>
+          <a:stretch>
+            <a:fillRect/>
+          </a:stretch>
+        </p:blipFill>
+        <p:spPr>
+          <a:xfrm>
+            <a:off x="1050013" y="1389888"/>
+            <a:ext cx="3432093" cy="4754880"/>
+          </a:xfrm>
+          <a:prstGeom prst="rect">
+            <a:avLst/>
+          </a:prstGeom>
+        </p:spPr>
+      </p:pic>
+      <p:sp>
+        <p:nvSpPr>
+          <p:cNvPr id="7" name="Rounded Rectangle 6"/>
           <p:cNvSpPr/>
           <p:nvPr/>
         </p:nvSpPr>
         <p:spPr>
           <a:xfrm>
-            <a:off x="7955279" y="1417320"/>
-            <a:ext cx="3794760" cy="2240280"/>
+            <a:off x="5303520" y="1280160"/>
+            <a:ext cx="6446520" cy="1554480"/>
           </a:xfrm>
           <a:prstGeom prst="roundRect">
             <a:avLst>
@@ -13169,14 +13182,14 @@
       </p:sp>
       <p:sp>
         <p:nvSpPr>
-          <p:cNvPr id="10" name="TextBox 9"/>
-          <p:cNvSpPr txBox="1"/>
-          <p:nvPr/>
-        </p:nvSpPr>
-        <p:spPr>
-          <a:xfrm>
-            <a:off x="8138160" y="1554480"/>
-            <a:ext cx="3474720" cy="365760"/>
+          <p:cNvPr id="8" name="TextBox 7"/>
+          <p:cNvSpPr txBox="1"/>
+          <p:nvPr/>
+        </p:nvSpPr>
+        <p:spPr>
+          <a:xfrm>
+            <a:off x="5486400" y="1389888"/>
+            <a:ext cx="6080760" cy="320040"/>
           </a:xfrm>
           <a:prstGeom prst="rect">
             <a:avLst/>
@@ -13204,21 +13217,21 @@
                 <a:ea typeface="Segoe UI"/>
                 <a:cs typeface="Segoe UI"/>
               </a:rPr>
-              <a:t>Плохое соглашение</a:t>
-            </a:r>
-          </a:p>
-        </p:txBody>
-      </p:sp>
-      <p:sp>
-        <p:nvSpPr>
-          <p:cNvPr id="11" name="TextBox 10"/>
-          <p:cNvSpPr txBox="1"/>
-          <p:nvPr/>
-        </p:nvSpPr>
-        <p:spPr>
-          <a:xfrm>
-            <a:off x="8138160" y="1965960"/>
-            <a:ext cx="3474720" cy="1463040"/>
+              <a:t>Сделка и процесс — разные вещи</a:t>
+            </a:r>
+          </a:p>
+        </p:txBody>
+      </p:sp>
+      <p:sp>
+        <p:nvSpPr>
+          <p:cNvPr id="9" name="TextBox 8"/>
+          <p:cNvSpPr txBox="1"/>
+          <p:nvPr/>
+        </p:nvSpPr>
+        <p:spPr>
+          <a:xfrm>
+            <a:off x="5486400" y="1783080"/>
+            <a:ext cx="6080760" cy="914400"/>
           </a:xfrm>
           <a:prstGeom prst="rect">
             <a:avLst/>
@@ -13238,7 +13251,7 @@
               </a:spcAft>
             </a:pPr>
             <a:r>
-              <a:rPr sz="1400" b="0">
+              <a:rPr sz="1500" b="0">
                 <a:solidFill>
                   <a:srgbClr val="203240"/>
                 </a:solidFill>
@@ -13246,21 +13259,21 @@
                 <a:ea typeface="Calibri"/>
                 <a:cs typeface="Calibri"/>
               </a:rPr>
-              <a:t>S2, урезанный пакет: соглашение слабое, полезность 20, процесс 44.12. Отношения и подготовка могут быть зачтены, аргументация — нет.</a:t>
-            </a:r>
-          </a:p>
-        </p:txBody>
-      </p:sp>
-      <p:sp>
-        <p:nvSpPr>
-          <p:cNvPr id="12" name="Rounded Rectangle 11"/>
+              <a:t>Полезность — про пакет. Балл процесса — про записанные действия. 100 из 100 — не компетентность человека.</a:t>
+            </a:r>
+          </a:p>
+        </p:txBody>
+      </p:sp>
+      <p:sp>
+        <p:nvSpPr>
+          <p:cNvPr id="10" name="Rounded Rectangle 9"/>
           <p:cNvSpPr/>
           <p:nvPr/>
         </p:nvSpPr>
         <p:spPr>
           <a:xfrm>
-            <a:off x="3840480" y="3794760"/>
-            <a:ext cx="3977639" cy="2514600"/>
+            <a:off x="5303520" y="2971800"/>
+            <a:ext cx="6446520" cy="1417320"/>
           </a:xfrm>
           <a:prstGeom prst="roundRect">
             <a:avLst>
@@ -13298,40 +13311,16 @@
           </a:p>
         </p:txBody>
       </p:sp>
-      <p:pic>
-        <p:nvPicPr>
-          <p:cNvPr id="13" name="Picture 12" descr="insufficient.png"/>
-          <p:cNvPicPr>
-            <a:picLocks noChangeAspect="1"/>
-          </p:cNvPicPr>
-          <p:nvPr/>
-        </p:nvPicPr>
-        <p:blipFill>
-          <a:blip r:embed="rId3"/>
-          <a:stretch>
-            <a:fillRect/>
-          </a:stretch>
-        </p:blipFill>
-        <p:spPr>
-          <a:xfrm>
-            <a:off x="4068931" y="3931920"/>
-            <a:ext cx="1371897" cy="2240280"/>
-          </a:xfrm>
-          <a:prstGeom prst="rect">
-            <a:avLst/>
-          </a:prstGeom>
-        </p:spPr>
-      </p:pic>
-      <p:sp>
-        <p:nvSpPr>
-          <p:cNvPr id="14" name="TextBox 13"/>
-          <p:cNvSpPr txBox="1"/>
-          <p:nvPr/>
-        </p:nvSpPr>
-        <p:spPr>
-          <a:xfrm>
-            <a:off x="5623560" y="4023360"/>
-            <a:ext cx="2011680" cy="2103120"/>
+      <p:sp>
+        <p:nvSpPr>
+          <p:cNvPr id="11" name="TextBox 10"/>
+          <p:cNvSpPr txBox="1"/>
+          <p:nvPr/>
+        </p:nvSpPr>
+        <p:spPr>
+          <a:xfrm>
+            <a:off x="5486400" y="3081528"/>
+            <a:ext cx="6080760" cy="320040"/>
           </a:xfrm>
           <a:prstGeom prst="rect">
             <a:avLst/>
@@ -13351,7 +13340,49 @@
               </a:spcAft>
             </a:pPr>
             <a:r>
-              <a:rPr sz="1400" b="0">
+              <a:rPr sz="1600" b="1">
+                <a:solidFill>
+                  <a:srgbClr val="183331"/>
+                </a:solidFill>
+                <a:latin typeface="Segoe UI"/>
+                <a:ea typeface="Segoe UI"/>
+                <a:cs typeface="Segoe UI"/>
+              </a:rPr>
+              <a:t>Слабое соглашение</a:t>
+            </a:r>
+          </a:p>
+        </p:txBody>
+      </p:sp>
+      <p:sp>
+        <p:nvSpPr>
+          <p:cNvPr id="12" name="TextBox 11"/>
+          <p:cNvSpPr txBox="1"/>
+          <p:nvPr/>
+        </p:nvSpPr>
+        <p:spPr>
+          <a:xfrm>
+            <a:off x="5486400" y="3456432"/>
+            <a:ext cx="6080760" cy="777240"/>
+          </a:xfrm>
+          <a:prstGeom prst="rect">
+            <a:avLst/>
+          </a:prstGeom>
+          <a:noFill/>
+        </p:spPr>
+        <p:txBody>
+          <a:bodyPr wrap="square"/>
+          <a:lstStyle/>
+          <a:p>
+            <a:pPr algn="l">
+              <a:spcBef>
+                <a:spcPts val="0"/>
+              </a:spcBef>
+              <a:spcAft>
+                <a:spcPts val="0"/>
+              </a:spcAft>
+            </a:pPr>
+            <a:r>
+              <a:rPr sz="1500" b="0">
                 <a:solidFill>
                   <a:srgbClr val="203240"/>
                 </a:solidFill>
@@ -13359,21 +13390,21 @@
                 <a:ea typeface="Calibri"/>
                 <a:cs typeface="Calibri"/>
               </a:rPr>
-              <a:t>Мало ходов или нет подготовки — «Недостаточно наблюдений». Приложение не выдумывает общий балл.</a:t>
-            </a:r>
-          </a:p>
-        </p:txBody>
-      </p:sp>
-      <p:sp>
-        <p:nvSpPr>
-          <p:cNvPr id="15" name="Rounded Rectangle 14"/>
+              <a:t>В нагрузке команды урезанный пакет: полезность 20, процесс 44.12. Подготовка может быть зачтена, аргументация — нет.</a:t>
+            </a:r>
+          </a:p>
+        </p:txBody>
+      </p:sp>
+      <p:sp>
+        <p:nvSpPr>
+          <p:cNvPr id="13" name="Rounded Rectangle 12"/>
           <p:cNvSpPr/>
           <p:nvPr/>
         </p:nvSpPr>
         <p:spPr>
           <a:xfrm>
-            <a:off x="7955279" y="3794760"/>
-            <a:ext cx="3794760" cy="2514600"/>
+            <a:off x="5303520" y="4526280"/>
+            <a:ext cx="6446520" cy="1737360"/>
           </a:xfrm>
           <a:prstGeom prst="roundRect">
             <a:avLst>
@@ -13413,14 +13444,14 @@
       </p:sp>
       <p:sp>
         <p:nvSpPr>
-          <p:cNvPr id="16" name="TextBox 15"/>
-          <p:cNvSpPr txBox="1"/>
-          <p:nvPr/>
-        </p:nvSpPr>
-        <p:spPr>
-          <a:xfrm>
-            <a:off x="8138160" y="3977639"/>
-            <a:ext cx="3474720" cy="365760"/>
+          <p:cNvPr id="14" name="TextBox 13"/>
+          <p:cNvSpPr txBox="1"/>
+          <p:nvPr/>
+        </p:nvSpPr>
+        <p:spPr>
+          <a:xfrm>
+            <a:off x="5486400" y="4636008"/>
+            <a:ext cx="6080760" cy="320040"/>
           </a:xfrm>
           <a:prstGeom prst="rect">
             <a:avLst/>
@@ -13455,14 +13486,14 @@
       </p:sp>
       <p:sp>
         <p:nvSpPr>
-          <p:cNvPr id="17" name="TextBox 16"/>
-          <p:cNvSpPr txBox="1"/>
-          <p:nvPr/>
-        </p:nvSpPr>
-        <p:spPr>
-          <a:xfrm>
-            <a:off x="8138160" y="4389120"/>
-            <a:ext cx="3474720" cy="1691640"/>
+          <p:cNvPr id="15" name="TextBox 14"/>
+          <p:cNvSpPr txBox="1"/>
+          <p:nvPr/>
+        </p:nvSpPr>
+        <p:spPr>
+          <a:xfrm>
+            <a:off x="5486400" y="5010912"/>
+            <a:ext cx="6080760" cy="1097280"/>
           </a:xfrm>
           <a:prstGeom prst="rect">
             <a:avLst/>
@@ -13482,7 +13513,7 @@
               </a:spcAft>
             </a:pPr>
             <a:r>
-              <a:rPr sz="1400" b="0">
+              <a:rPr sz="1500" b="0">
                 <a:solidFill>
                   <a:srgbClr val="203240"/>
                 </a:solidFill>
@@ -13490,14 +13521,14 @@
                 <a:ea typeface="Calibri"/>
                 <a:cs typeface="Calibri"/>
               </a:rPr>
-              <a:t>Рекомендация привязана к проваленной проверке и предлагается как альтернатива. Она не обещает, что оппонент согласится.</a:t>
-            </a:r>
-          </a:p>
-        </p:txBody>
-      </p:sp>
-      <p:sp>
-        <p:nvSpPr>
-          <p:cNvPr id="18" name="TextBox 17"/>
+              <a:t>Совет привязан к непройденной проверке и не обещает согласия. Мало ходов или нет подготовки — «Недостаточно наблюдений», общего балла нет.</a:t>
+            </a:r>
+          </a:p>
+        </p:txBody>
+      </p:sp>
+      <p:sp>
+        <p:nvSpPr>
+          <p:cNvPr id="16" name="TextBox 15"/>
           <p:cNvSpPr txBox="1"/>
           <p:nvPr/>
         </p:nvSpPr>
@@ -13539,7 +13570,7 @@
       </p:sp>
       <p:sp>
         <p:nvSpPr>
-          <p:cNvPr id="19" name="TextBox 18"/>
+          <p:cNvPr id="17" name="TextBox 16"/>
           <p:cNvSpPr txBox="1"/>
           <p:nvPr/>
         </p:nvSpPr>
@@ -14075,7 +14106,7 @@
                 <a:ea typeface="Segoe UI"/>
                 <a:cs typeface="Segoe UI"/>
               </a:rPr>
-              <a:t>Администратор / наставник</a:t>
+              <a:t>Администратор и наставник</a:t>
             </a:r>
           </a:p>
         </p:txBody>
@@ -14117,7 +14148,7 @@
                 <a:ea typeface="Calibri"/>
                 <a:cs typeface="Calibri"/>
               </a:rPr>
-              <a:t>Готовит занятие, не играет оппонента</a:t>
+              <a:t>Готовят занятие, не играют оппонента</a:t>
             </a:r>
           </a:p>
         </p:txBody>
@@ -14159,7 +14190,7 @@
                 <a:ea typeface="Calibri"/>
                 <a:cs typeface="Calibri"/>
               </a:rPr>
-              <a:t>Шесть настроек, проверка достижимости, публикация, разбор по действиям ученика. Дополняет тренера, не заменяет его.</a:t>
+              <a:t>Администратор публикует ситуацию. Отчёт видит сам игрок. Наставник разбирает его вместе с игроком, на экране игрока.</a:t>
             </a:r>
           </a:p>
         </p:txBody>
@@ -15363,8 +15394,8 @@
         </p:nvSpPr>
         <p:spPr>
           <a:xfrm>
-            <a:off x="411480" y="4023360"/>
-            <a:ext cx="11338560" cy="2194560"/>
+            <a:off x="411480" y="4069080"/>
+            <a:ext cx="11338560" cy="2148840"/>
           </a:xfrm>
           <a:prstGeom prst="roundRect">
             <a:avLst>
@@ -15410,7 +15441,7 @@
         </p:nvSpPr>
         <p:spPr>
           <a:xfrm>
-            <a:off x="640080" y="4160520"/>
+            <a:off x="640080" y="4251960"/>
             <a:ext cx="10972800" cy="320040"/>
           </a:xfrm>
           <a:prstGeom prst="rect">
@@ -15452,7 +15483,7 @@
         </p:nvSpPr>
         <p:spPr>
           <a:xfrm>
-            <a:off x="640080" y="4526280"/>
+            <a:off x="640080" y="4663440"/>
             <a:ext cx="10972800" cy="640080"/>
           </a:xfrm>
           <a:prstGeom prst="rect">
@@ -15481,7 +15512,7 @@
                 <a:ea typeface="Calibri"/>
                 <a:cs typeface="Calibri"/>
               </a:rPr>
-              <a:t>Можно спорить с решением, открыв ход. Нельзя получить другой исход из тех же сохранённых действий «потому что модель передумала».</a:t>
+              <a:t>Можно открыть ход и сверить вывод. Те же сохранённые действия на той же версии не меняют исход сами по себе.</a:t>
             </a:r>
           </a:p>
         </p:txBody>
@@ -15494,8 +15525,8 @@
         </p:nvSpPr>
         <p:spPr>
           <a:xfrm>
-            <a:off x="640080" y="5212080"/>
-            <a:ext cx="10972800" cy="731520"/>
+            <a:off x="640080" y="5394960"/>
+            <a:ext cx="10972800" cy="594360"/>
           </a:xfrm>
           <a:prstGeom prst="rect">
             <a:avLst/>
@@ -15523,7 +15554,7 @@
                 <a:ea typeface="Calibri"/>
                 <a:cs typeface="Calibri"/>
               </a:rPr>
-              <a:t>Стек (вторично): веб-приложение, Fastify и React, SQLite. Локальный показ на 127.0.0.1. После Stop/Start попытка сохраняется. Вход и владение сессией проверены на loopback HTTP — это не сертификат корпоративной безопасности и не публичный сайт.</a:t>
+              <a:t>Веб, Fastify, React, SQLite. Локальный запуск; остановка и новый старт сохраняют попытку. Это не публичный сайт.</a:t>
             </a:r>
           </a:p>
         </p:txBody>
@@ -15760,7 +15791,7 @@
                 <a:ea typeface="Segoe UI"/>
                 <a:cs typeface="Segoe UI"/>
               </a:rPr>
-              <a:t>Guided-цикл работает сейчас. Свободный диалог — впереди</a:t>
+              <a:t>Выбор действий работает сейчас. Свободный диалог — впереди</a:t>
             </a:r>
           </a:p>
         </p:txBody>
@@ -16407,7 +16438,7 @@
                 <a:ea typeface="Calibri"/>
                 <a:cs typeface="Calibri"/>
               </a:rPr>
-              <a:t>○  Качество адаптера Qwen отдельно не принято.</a:t>
+              <a:t>○  Модель Qwen ещё не встроена и не проверена.</a:t>
             </a:r>
           </a:p>
         </p:txBody>
@@ -16449,7 +16480,7 @@
                 <a:ea typeface="Calibri"/>
                 <a:cs typeface="Calibri"/>
               </a:rPr>
-              <a:t>○  Публичный HTTPS и чужая машина жюри — не сертифицированы.</a:t>
+              <a:t>○  Публичный сайт и запуск на чужом компьютере не проверялись.</a:t>
             </a:r>
           </a:p>
         </p:txBody>

</xml_diff>